<commit_message>
refactor: rename PPTSKILL to SlideLoom across skill, docs and visual identity
</commit_message>
<xml_diff>
--- a/examples/style-showcase.pptx
+++ b/examples/style-showcase.pptx
@@ -444,7 +444,7 @@
           <a:lstStyle xmlns:a="http://schemas.openxmlformats.org/drawingml/2006/main"/>
           <a:p xmlns:a="http://schemas.openxmlformats.org/drawingml/2006/main">
             <a:r>
-              <a:t>本页使用虚构数据演示 PPTSKILL 的视觉预设，不代表真实企业或研究。旧方案 54/100，新方案 72/100。差异为 18 个百分点，不能据此作因果推断。图表为原生图表，来源为本仓库 examples/storyboard.md 的示例情境。</a:t>
+              <a:t>本页使用虚构数据演示 SlideLoom 的视觉预设，不代表真实企业或研究。旧方案 54/100，新方案 72/100。差异为 18 个百分点，不能据此作因果推断。图表为原生图表，来源为本仓库 examples/storyboard.md 的示例情境。</a:t>
             </a:r>
           </a:p>
         </p:txBody>
@@ -514,7 +514,7 @@
           <a:lstStyle xmlns:a="http://schemas.openxmlformats.org/drawingml/2006/main"/>
           <a:p xmlns:a="http://schemas.openxmlformats.org/drawingml/2006/main">
             <a:r>
-              <a:t>本页使用虚构数据演示 PPTSKILL 的视觉预设，不代表真实企业或研究。旧方案 54/100，新方案 72/100。差异为 18 个百分点，不能据此作因果推断。图表为原生图表，来源为本仓库 examples/storyboard.md 的示例情境。</a:t>
+              <a:t>本页使用虚构数据演示 SlideLoom 的视觉预设，不代表真实企业或研究。旧方案 54/100，新方案 72/100。差异为 18 个百分点，不能据此作因果推断。图表为原生图表，来源为本仓库 examples/storyboard.md 的示例情境。</a:t>
             </a:r>
           </a:p>
         </p:txBody>
@@ -584,7 +584,7 @@
           <a:lstStyle xmlns:a="http://schemas.openxmlformats.org/drawingml/2006/main"/>
           <a:p xmlns:a="http://schemas.openxmlformats.org/drawingml/2006/main">
             <a:r>
-              <a:t>本页使用虚构数据演示 PPTSKILL 的视觉预设，不代表真实企业或研究。旧方案 54/100，新方案 72/100。差异为 18 个百分点，不能据此作因果推断。图表为原生图表，来源为本仓库 examples/storyboard.md 的示例情境。</a:t>
+              <a:t>本页使用虚构数据演示 SlideLoom 的视觉预设，不代表真实企业或研究。旧方案 54/100，新方案 72/100。差异为 18 个百分点，不能据此作因果推断。图表为原生图表，来源为本仓库 examples/storyboard.md 的示例情境。</a:t>
             </a:r>
           </a:p>
         </p:txBody>

</xml_diff>